<commit_message>
Sales kit: reshoot docs/media and rebuild the deck with true inventory
The deck still sold the title sponsorship as OPEN weeks after Ho-Chunk
bought it, promised a season-calendar download that no longer exists,
and set a "before Week 1" deadline. Slot status now reads from
SPONSORS in src/config.js (the same source as the hosted media kit), so
the deck can't drift again; sold slots get a filled chip. Screenshots
box-fit their frames, so a taller hero state can't run off slide 5.

Co-Authored-By: Claude Opus 5.5 <noreply@anthropic.com>
</commit_message>
<xml_diff>
--- a/docs/sponsor-deck.pptx
+++ b/docs/sponsor-deck.pptx
@@ -3562,7 +3562,7 @@
                 <a:ea typeface="Calibri" pitchFamily="34" charset="-122"/>
                 <a:cs typeface="Calibri" pitchFamily="34" charset="-120"/>
               </a:rPr>
-              <a:t>Alerts + calendar</a:t>
+              <a:t>Alerts + share cards</a:t>
             </a:r>
             <a:endParaRPr lang="en-US" sz="1250" dirty="0"/>
           </a:p>
@@ -3604,7 +3604,7 @@
                 <a:ea typeface="Calibri" pitchFamily="34" charset="-122"/>
                 <a:cs typeface="Calibri" pitchFamily="34" charset="-120"/>
               </a:rPr>
-              <a:t>Kickoff alerts and a one-click season calendar download</a:t>
+              <a:t>Opt-in kickoff alerts, and stat cards readers post straight to their feeds</a:t>
             </a:r>
             <a:endParaRPr lang="en-US" sz="1050" dirty="0"/>
           </a:p>
@@ -4568,11 +4568,11 @@
             <a:avLst/>
           </a:prstGeom>
           <a:solidFill>
-            <a:srgbClr val="FFFFFF"/>
+            <a:srgbClr val="203731"/>
           </a:solidFill>
           <a:ln w="12700">
             <a:solidFill>
-              <a:srgbClr val="8A6D00"/>
+              <a:srgbClr val="203731"/>
             </a:solidFill>
           </a:ln>
         </p:spPr>
@@ -4586,13 +4586,13 @@
             <a:r>
               <a:rPr lang="en-US" sz="950" b="1" dirty="0">
                 <a:solidFill>
-                  <a:srgbClr val="203731"/>
-                </a:solidFill>
-                <a:latin typeface="Calibri" pitchFamily="34" charset="0"/>
-                <a:ea typeface="Calibri" pitchFamily="34" charset="-122"/>
-                <a:cs typeface="Calibri" pitchFamily="34" charset="-120"/>
-              </a:rPr>
-              <a:t>OPEN</a:t>
+                  <a:srgbClr val="FFFFFF"/>
+                </a:solidFill>
+                <a:latin typeface="Calibri" pitchFamily="34" charset="0"/>
+                <a:ea typeface="Calibri" pitchFamily="34" charset="-122"/>
+                <a:cs typeface="Calibri" pitchFamily="34" charset="-120"/>
+              </a:rPr>
+              <a:t>SOLD</a:t>
             </a:r>
             <a:endParaRPr lang="en-US" sz="950" dirty="0"/>
           </a:p>
@@ -5431,7 +5431,7 @@
         <p:spPr>
           <a:xfrm>
             <a:off x="493776" y="1298448"/>
-            <a:ext cx="4992624" cy="1842516"/>
+            <a:ext cx="4261104" cy="1586484"/>
           </a:xfrm>
           <a:prstGeom prst="rect">
             <a:avLst/>
@@ -5471,7 +5471,7 @@
         <p:spPr>
           <a:xfrm>
             <a:off x="566928" y="1371600"/>
-            <a:ext cx="4846320" cy="1696212"/>
+            <a:ext cx="4114800" cy="1440180"/>
           </a:xfrm>
           <a:prstGeom prst="rect">
             <a:avLst/>
@@ -5486,8 +5486,8 @@
         </p:nvSpPr>
         <p:spPr>
           <a:xfrm>
-            <a:off x="493776" y="3035808"/>
-            <a:ext cx="4306824" cy="1934337"/>
+            <a:off x="493776" y="2994660"/>
+            <a:ext cx="3110233" cy="1970532"/>
           </a:xfrm>
           <a:prstGeom prst="rect">
             <a:avLst/>
@@ -5526,8 +5526,8 @@
         </p:blipFill>
         <p:spPr>
           <a:xfrm>
-            <a:off x="566928" y="3108960"/>
-            <a:ext cx="4160520" cy="1788033"/>
+            <a:off x="566928" y="3067812"/>
+            <a:ext cx="2963929" cy="1824228"/>
           </a:xfrm>
           <a:prstGeom prst="rect">
             <a:avLst/>
@@ -5542,8 +5542,8 @@
         </p:nvSpPr>
         <p:spPr>
           <a:xfrm>
-            <a:off x="5916168" y="1298448"/>
-            <a:ext cx="2478024" cy="1667474"/>
+            <a:off x="5995684" y="1298448"/>
+            <a:ext cx="2654540" cy="2935224"/>
           </a:xfrm>
           <a:prstGeom prst="rect">
             <a:avLst/>
@@ -5582,8 +5582,8 @@
         </p:blipFill>
         <p:spPr>
           <a:xfrm>
-            <a:off x="5989320" y="1371600"/>
-            <a:ext cx="2331720" cy="1521170"/>
+            <a:off x="6068836" y="1371600"/>
+            <a:ext cx="2508236" cy="2788920"/>
           </a:xfrm>
           <a:prstGeom prst="rect">
             <a:avLst/>
@@ -5598,20 +5598,23 @@
         </p:nvSpPr>
         <p:spPr>
           <a:xfrm>
-            <a:off x="566928" y="4937760"/>
-            <a:ext cx="8046720" cy="201168"/>
-          </a:xfrm>
-          <a:prstGeom prst="rect">
-            <a:avLst/>
-          </a:prstGeom>
-          <a:noFill/>
-          <a:ln/>
-        </p:spPr>
-        <p:txBody>
-          <a:bodyPr wrap="square" lIns="0" tIns="0" rIns="0" bIns="0" rtlCol="0" anchor="ctr"/>
-          <a:lstStyle/>
-          <a:p>
-            <a:pPr indent="0" marL="0">
+            <a:off x="6068836" y="4361688"/>
+            <a:ext cx="2508236" cy="566928"/>
+          </a:xfrm>
+          <a:prstGeom prst="rect">
+            <a:avLst/>
+          </a:prstGeom>
+          <a:noFill/>
+          <a:ln/>
+        </p:spPr>
+        <p:txBody>
+          <a:bodyPr wrap="square" lIns="0" tIns="0" rIns="0" bIns="0" rtlCol="0" anchor="t"/>
+          <a:lstStyle/>
+          <a:p>
+            <a:pPr indent="0" marL="0">
+              <a:lnSpc>
+                <a:spcPts val="1200"/>
+              </a:lnSpc>
               <a:buNone/>
             </a:pPr>
             <a:r>
@@ -5623,7 +5626,7 @@
                 <a:ea typeface="Calibri" pitchFamily="34" charset="-122"/>
                 <a:cs typeface="Calibri" pitchFamily="34" charset="-120"/>
               </a:rPr>
-              <a:t>Left: the title lockup + game hero in sales-demo mode (?demo). Right: the newsletter digest — your logo rides along twice a day.</a:t>
+              <a:t>Left: the title lockup and game hero in sales-demo mode (?demo). Right: the newsletter digest — your logo rides along twice a day.</a:t>
             </a:r>
             <a:endParaRPr lang="en-US" sz="950" dirty="0"/>
           </a:p>
@@ -5816,7 +5819,7 @@
                 <a:ea typeface="Calibri" pitchFamily="34" charset="-122"/>
                 <a:cs typeface="Calibri" pitchFamily="34" charset="-120"/>
               </a:rPr>
-              <a:t>Lives in their calendar</a:t>
+              <a:t>Stat cards carry the credit</a:t>
             </a:r>
             <a:endParaRPr lang="en-US" sz="1300" dirty="0"/>
           </a:p>
@@ -5858,7 +5861,7 @@
                 <a:ea typeface="Calibri" pitchFamily="34" charset="-122"/>
                 <a:cs typeface="Calibri" pitchFamily="34" charset="-120"/>
               </a:rPr>
-              <a:t>The season-schedule download carries the title sponsor's credit into every kickoff on readers' own phones</a:t>
+              <a:t>Readers share the season's numbers as image cards — each one signed “Presented by” the title sponsor</a:t>
             </a:r>
             <a:endParaRPr lang="en-US" sz="1050" dirty="0"/>
           </a:p>
@@ -7372,7 +7375,7 @@
                 <a:ea typeface="Calibri" pitchFamily="34" charset="-122"/>
                 <a:cs typeface="Calibri" pitchFamily="34" charset="-120"/>
               </a:rPr>
-              <a:t>Packages run from a single-section credit to title sponsorship of the page. Slots activate the same day they're sold — before Week 1 puts the whole state on this page — and your live dashboard link comes with the first invoice.</a:t>
+              <a:t>Packages run from a single-section credit to title sponsorship of the page. Slots activate the same day they're sold, for every game still to play — and your live dashboard link comes with the first invoice.</a:t>
             </a:r>
             <a:endParaRPr lang="en-US" sz="1400" dirty="0"/>
           </a:p>

</xml_diff>

<commit_message>
Sales kit: reshoot on the Buccaneers preview; film room shows a win
The game card in the deck showed the 35-14 Falcons loss; it now shows
the Week 4 preview at Tampa. media-shots.mjs shoots the film room on
the latest WIN rather than the latest game (a sales shot wants the
chart that climbs, and the turning-point callout only reads right in a
win) and crops at the tab bar so the bookmark button stays out.

Co-Authored-By: Claude Opus 5.5 <noreply@anthropic.com>
</commit_message>
<xml_diff>
--- a/docs/sponsor-deck.pptx
+++ b/docs/sponsor-deck.pptx
@@ -5487,7 +5487,7 @@
         <p:spPr>
           <a:xfrm>
             <a:off x="493776" y="2994660"/>
-            <a:ext cx="3110233" cy="1970532"/>
+            <a:ext cx="4261104" cy="1914688"/>
           </a:xfrm>
           <a:prstGeom prst="rect">
             <a:avLst/>
@@ -5527,7 +5527,7 @@
         <p:spPr>
           <a:xfrm>
             <a:off x="566928" y="3067812"/>
-            <a:ext cx="2963929" cy="1824228"/>
+            <a:ext cx="4114800" cy="1768384"/>
           </a:xfrm>
           <a:prstGeom prst="rect">
             <a:avLst/>

</xml_diff>